<commit_message>
Fix error in Volcano_MDP_Final_Presentation
</commit_message>
<xml_diff>
--- a/others/Volcano_MDP_Final_Presentation.pptx
+++ b/others/Volcano_MDP_Final_Presentation.pptx
@@ -23146,7 +23146,11 @@
         <p:nvSpPr>
           <p:cNvPr id="8" name="Shape 6"/>
           <p:cNvSpPr/>
-          <p:nvPr/>
+          <p:nvPr>
+            <p:custDataLst>
+              <p:tags r:id="rId1"/>
+            </p:custDataLst>
+          </p:nvPr>
         </p:nvSpPr>
         <p:spPr>
           <a:xfrm>
@@ -23173,7 +23177,11 @@
         <p:nvSpPr>
           <p:cNvPr id="9" name="Text 7"/>
           <p:cNvSpPr/>
-          <p:nvPr/>
+          <p:nvPr>
+            <p:custDataLst>
+              <p:tags r:id="rId2"/>
+            </p:custDataLst>
+          </p:nvPr>
         </p:nvSpPr>
         <p:spPr>
           <a:xfrm>
@@ -23216,7 +23224,11 @@
         <p:nvSpPr>
           <p:cNvPr id="10" name="Text 8"/>
           <p:cNvSpPr/>
-          <p:nvPr/>
+          <p:nvPr>
+            <p:custDataLst>
+              <p:tags r:id="rId3"/>
+            </p:custDataLst>
+          </p:nvPr>
         </p:nvSpPr>
         <p:spPr>
           <a:xfrm>
@@ -23259,7 +23271,11 @@
         <p:nvSpPr>
           <p:cNvPr id="11" name="Text 9"/>
           <p:cNvSpPr/>
-          <p:nvPr/>
+          <p:nvPr>
+            <p:custDataLst>
+              <p:tags r:id="rId4"/>
+            </p:custDataLst>
+          </p:nvPr>
         </p:nvSpPr>
         <p:spPr>
           <a:xfrm>
@@ -23302,7 +23318,11 @@
         <p:nvSpPr>
           <p:cNvPr id="12" name="Shape 10"/>
           <p:cNvSpPr/>
-          <p:nvPr/>
+          <p:nvPr>
+            <p:custDataLst>
+              <p:tags r:id="rId5"/>
+            </p:custDataLst>
+          </p:nvPr>
         </p:nvSpPr>
         <p:spPr>
           <a:xfrm>
@@ -23329,7 +23349,11 @@
         <p:nvSpPr>
           <p:cNvPr id="13" name="Text 11"/>
           <p:cNvSpPr/>
-          <p:nvPr/>
+          <p:nvPr>
+            <p:custDataLst>
+              <p:tags r:id="rId6"/>
+            </p:custDataLst>
+          </p:nvPr>
         </p:nvSpPr>
         <p:spPr>
           <a:xfrm>
@@ -23372,7 +23396,11 @@
         <p:nvSpPr>
           <p:cNvPr id="14" name="Text 12"/>
           <p:cNvSpPr/>
-          <p:nvPr/>
+          <p:nvPr>
+            <p:custDataLst>
+              <p:tags r:id="rId7"/>
+            </p:custDataLst>
+          </p:nvPr>
         </p:nvSpPr>
         <p:spPr>
           <a:xfrm>
@@ -23415,7 +23443,11 @@
         <p:nvSpPr>
           <p:cNvPr id="15" name="Text 13"/>
           <p:cNvSpPr/>
-          <p:nvPr/>
+          <p:nvPr>
+            <p:custDataLst>
+              <p:tags r:id="rId8"/>
+            </p:custDataLst>
+          </p:nvPr>
         </p:nvSpPr>
         <p:spPr>
           <a:xfrm>
@@ -23458,7 +23490,11 @@
         <p:nvSpPr>
           <p:cNvPr id="16" name="Shape 14"/>
           <p:cNvSpPr/>
-          <p:nvPr/>
+          <p:nvPr>
+            <p:custDataLst>
+              <p:tags r:id="rId9"/>
+            </p:custDataLst>
+          </p:nvPr>
         </p:nvSpPr>
         <p:spPr>
           <a:xfrm>
@@ -23485,7 +23521,11 @@
         <p:nvSpPr>
           <p:cNvPr id="17" name="Text 15"/>
           <p:cNvSpPr/>
-          <p:nvPr/>
+          <p:nvPr>
+            <p:custDataLst>
+              <p:tags r:id="rId10"/>
+            </p:custDataLst>
+          </p:nvPr>
         </p:nvSpPr>
         <p:spPr>
           <a:xfrm>
@@ -23518,7 +23558,7 @@
                 <a:ea typeface="Space Grotesk" pitchFamily="34" charset="-122"/>
                 <a:cs typeface="Space Grotesk" pitchFamily="34" charset="-120"/>
               </a:rPr>
-              <a:t>P</a:t>
+              <a:t>T</a:t>
             </a:r>
             <a:endParaRPr lang="en-US" sz="1355" dirty="0"/>
           </a:p>
@@ -23528,7 +23568,11 @@
         <p:nvSpPr>
           <p:cNvPr id="18" name="Text 16"/>
           <p:cNvSpPr/>
-          <p:nvPr/>
+          <p:nvPr>
+            <p:custDataLst>
+              <p:tags r:id="rId11"/>
+            </p:custDataLst>
+          </p:nvPr>
         </p:nvSpPr>
         <p:spPr>
           <a:xfrm>
@@ -23571,7 +23615,11 @@
         <p:nvSpPr>
           <p:cNvPr id="19" name="Text 17"/>
           <p:cNvSpPr/>
-          <p:nvPr/>
+          <p:nvPr>
+            <p:custDataLst>
+              <p:tags r:id="rId12"/>
+            </p:custDataLst>
+          </p:nvPr>
         </p:nvSpPr>
         <p:spPr>
           <a:xfrm>
@@ -23614,7 +23662,11 @@
         <p:nvSpPr>
           <p:cNvPr id="20" name="Shape 18"/>
           <p:cNvSpPr/>
-          <p:nvPr/>
+          <p:nvPr>
+            <p:custDataLst>
+              <p:tags r:id="rId13"/>
+            </p:custDataLst>
+          </p:nvPr>
         </p:nvSpPr>
         <p:spPr>
           <a:xfrm>
@@ -23641,7 +23693,11 @@
         <p:nvSpPr>
           <p:cNvPr id="21" name="Text 19"/>
           <p:cNvSpPr/>
-          <p:nvPr/>
+          <p:nvPr>
+            <p:custDataLst>
+              <p:tags r:id="rId14"/>
+            </p:custDataLst>
+          </p:nvPr>
         </p:nvSpPr>
         <p:spPr>
           <a:xfrm>
@@ -23684,7 +23740,11 @@
         <p:nvSpPr>
           <p:cNvPr id="22" name="Text 20"/>
           <p:cNvSpPr/>
-          <p:nvPr/>
+          <p:nvPr>
+            <p:custDataLst>
+              <p:tags r:id="rId15"/>
+            </p:custDataLst>
+          </p:nvPr>
         </p:nvSpPr>
         <p:spPr>
           <a:xfrm>
@@ -23727,7 +23787,11 @@
         <p:nvSpPr>
           <p:cNvPr id="23" name="Text 21"/>
           <p:cNvSpPr/>
-          <p:nvPr/>
+          <p:nvPr>
+            <p:custDataLst>
+              <p:tags r:id="rId16"/>
+            </p:custDataLst>
+          </p:nvPr>
         </p:nvSpPr>
         <p:spPr>
           <a:xfrm>
@@ -23770,7 +23834,11 @@
         <p:nvSpPr>
           <p:cNvPr id="24" name="Shape 22"/>
           <p:cNvSpPr/>
-          <p:nvPr/>
+          <p:nvPr>
+            <p:custDataLst>
+              <p:tags r:id="rId17"/>
+            </p:custDataLst>
+          </p:nvPr>
         </p:nvSpPr>
         <p:spPr>
           <a:xfrm>
@@ -23797,7 +23865,11 @@
         <p:nvSpPr>
           <p:cNvPr id="25" name="Text 23"/>
           <p:cNvSpPr/>
-          <p:nvPr/>
+          <p:nvPr>
+            <p:custDataLst>
+              <p:tags r:id="rId18"/>
+            </p:custDataLst>
+          </p:nvPr>
         </p:nvSpPr>
         <p:spPr>
           <a:xfrm>
@@ -23840,7 +23912,11 @@
         <p:nvSpPr>
           <p:cNvPr id="26" name="Text 24"/>
           <p:cNvSpPr/>
-          <p:nvPr/>
+          <p:nvPr>
+            <p:custDataLst>
+              <p:tags r:id="rId19"/>
+            </p:custDataLst>
+          </p:nvPr>
         </p:nvSpPr>
         <p:spPr>
           <a:xfrm>
@@ -23883,7 +23959,11 @@
         <p:nvSpPr>
           <p:cNvPr id="27" name="Text 25"/>
           <p:cNvSpPr/>
-          <p:nvPr/>
+          <p:nvPr>
+            <p:custDataLst>
+              <p:tags r:id="rId20"/>
+            </p:custDataLst>
+          </p:nvPr>
         </p:nvSpPr>
         <p:spPr>
           <a:xfrm>
@@ -30535,79 +30615,79 @@
 
 <file path=ppt/tags/tag1.xml><?xml version="1.0" encoding="utf-8"?>
 <p:tagLst xmlns:p="http://schemas.openxmlformats.org/presentationml/2006/main">
-  <p:tag name="KSO_WM_DIAGRAM_VIRTUALLY_FRAME" val="{&quot;height&quot;:112.5,&quot;left&quot;:166.95,&quot;top&quot;:214.5,&quot;width&quot;:499.05}"/>
+  <p:tag name="KSO_WM_DIAGRAM_VIRTUALLY_FRAME" val="{&quot;height&quot;:204,&quot;left&quot;:52.5,&quot;top&quot;:169.5,&quot;width&quot;:326.25}"/>
 </p:tagLst>
 </file>
 
 <file path=ppt/tags/tag10.xml><?xml version="1.0" encoding="utf-8"?>
 <p:tagLst xmlns:p="http://schemas.openxmlformats.org/presentationml/2006/main">
-  <p:tag name="KSO_WM_DIAGRAM_VIRTUALLY_FRAME" val="{&quot;height&quot;:112.5,&quot;left&quot;:166.95,&quot;top&quot;:214.5,&quot;width&quot;:499.05}"/>
+  <p:tag name="KSO_WM_DIAGRAM_VIRTUALLY_FRAME" val="{&quot;height&quot;:204,&quot;left&quot;:52.5,&quot;top&quot;:169.5,&quot;width&quot;:326.25}"/>
 </p:tagLst>
 </file>
 
 <file path=ppt/tags/tag11.xml><?xml version="1.0" encoding="utf-8"?>
 <p:tagLst xmlns:p="http://schemas.openxmlformats.org/presentationml/2006/main">
-  <p:tag name="KSO_WM_DIAGRAM_VIRTUALLY_FRAME" val="{&quot;height&quot;:112.5,&quot;left&quot;:166.95,&quot;top&quot;:214.5,&quot;width&quot;:499.05}"/>
+  <p:tag name="KSO_WM_DIAGRAM_VIRTUALLY_FRAME" val="{&quot;height&quot;:204,&quot;left&quot;:52.5,&quot;top&quot;:169.5,&quot;width&quot;:326.25}"/>
 </p:tagLst>
 </file>
 
 <file path=ppt/tags/tag12.xml><?xml version="1.0" encoding="utf-8"?>
 <p:tagLst xmlns:p="http://schemas.openxmlformats.org/presentationml/2006/main">
-  <p:tag name="KSO_WM_DIAGRAM_VIRTUALLY_FRAME" val="{&quot;height&quot;:112.5,&quot;left&quot;:166.95,&quot;top&quot;:214.5,&quot;width&quot;:499.05}"/>
+  <p:tag name="KSO_WM_DIAGRAM_VIRTUALLY_FRAME" val="{&quot;height&quot;:204,&quot;left&quot;:52.5,&quot;top&quot;:169.5,&quot;width&quot;:326.25}"/>
 </p:tagLst>
 </file>
 
 <file path=ppt/tags/tag13.xml><?xml version="1.0" encoding="utf-8"?>
 <p:tagLst xmlns:p="http://schemas.openxmlformats.org/presentationml/2006/main">
-  <p:tag name="KSO_WM_DIAGRAM_VIRTUALLY_FRAME" val="{&quot;height&quot;:112.5,&quot;left&quot;:166.95,&quot;top&quot;:214.5,&quot;width&quot;:499.05}"/>
+  <p:tag name="KSO_WM_DIAGRAM_VIRTUALLY_FRAME" val="{&quot;height&quot;:204,&quot;left&quot;:52.5,&quot;top&quot;:169.5,&quot;width&quot;:326.25}"/>
 </p:tagLst>
 </file>
 
 <file path=ppt/tags/tag14.xml><?xml version="1.0" encoding="utf-8"?>
 <p:tagLst xmlns:p="http://schemas.openxmlformats.org/presentationml/2006/main">
-  <p:tag name="KSO_WM_DIAGRAM_VIRTUALLY_FRAME" val="{&quot;height&quot;:112.5,&quot;left&quot;:166.95,&quot;top&quot;:214.5,&quot;width&quot;:499.05}"/>
+  <p:tag name="KSO_WM_DIAGRAM_VIRTUALLY_FRAME" val="{&quot;height&quot;:204,&quot;left&quot;:52.5,&quot;top&quot;:169.5,&quot;width&quot;:326.25}"/>
 </p:tagLst>
 </file>
 
 <file path=ppt/tags/tag15.xml><?xml version="1.0" encoding="utf-8"?>
 <p:tagLst xmlns:p="http://schemas.openxmlformats.org/presentationml/2006/main">
-  <p:tag name="KSO_WM_DIAGRAM_VIRTUALLY_FRAME" val="{&quot;height&quot;:112.5,&quot;left&quot;:166.95,&quot;top&quot;:214.5,&quot;width&quot;:499.05}"/>
+  <p:tag name="KSO_WM_DIAGRAM_VIRTUALLY_FRAME" val="{&quot;height&quot;:204,&quot;left&quot;:52.5,&quot;top&quot;:169.5,&quot;width&quot;:326.25}"/>
 </p:tagLst>
 </file>
 
 <file path=ppt/tags/tag16.xml><?xml version="1.0" encoding="utf-8"?>
 <p:tagLst xmlns:p="http://schemas.openxmlformats.org/presentationml/2006/main">
-  <p:tag name="KSO_WM_DIAGRAM_VIRTUALLY_FRAME" val="{&quot;height&quot;:112.5,&quot;left&quot;:166.95,&quot;top&quot;:214.5,&quot;width&quot;:499.05}"/>
+  <p:tag name="KSO_WM_DIAGRAM_VIRTUALLY_FRAME" val="{&quot;height&quot;:204,&quot;left&quot;:52.5,&quot;top&quot;:169.5,&quot;width&quot;:326.25}"/>
 </p:tagLst>
 </file>
 
 <file path=ppt/tags/tag17.xml><?xml version="1.0" encoding="utf-8"?>
 <p:tagLst xmlns:p="http://schemas.openxmlformats.org/presentationml/2006/main">
-  <p:tag name="KSO_WM_DIAGRAM_VIRTUALLY_FRAME" val="{&quot;height&quot;:112.5,&quot;left&quot;:166.95,&quot;top&quot;:214.5,&quot;width&quot;:499.05}"/>
+  <p:tag name="KSO_WM_DIAGRAM_VIRTUALLY_FRAME" val="{&quot;height&quot;:204,&quot;left&quot;:52.5,&quot;top&quot;:169.5,&quot;width&quot;:326.25}"/>
 </p:tagLst>
 </file>
 
 <file path=ppt/tags/tag18.xml><?xml version="1.0" encoding="utf-8"?>
 <p:tagLst xmlns:p="http://schemas.openxmlformats.org/presentationml/2006/main">
-  <p:tag name="KSO_WM_DIAGRAM_VIRTUALLY_FRAME" val="{&quot;height&quot;:112.5,&quot;left&quot;:166.95,&quot;top&quot;:214.5,&quot;width&quot;:499.05}"/>
+  <p:tag name="KSO_WM_DIAGRAM_VIRTUALLY_FRAME" val="{&quot;height&quot;:204,&quot;left&quot;:52.5,&quot;top&quot;:169.5,&quot;width&quot;:326.25}"/>
 </p:tagLst>
 </file>
 
 <file path=ppt/tags/tag19.xml><?xml version="1.0" encoding="utf-8"?>
 <p:tagLst xmlns:p="http://schemas.openxmlformats.org/presentationml/2006/main">
-  <p:tag name="KSO_WM_DIAGRAM_VIRTUALLY_FRAME" val="{&quot;height&quot;:112.5,&quot;left&quot;:166.95,&quot;top&quot;:214.5,&quot;width&quot;:499.05}"/>
+  <p:tag name="KSO_WM_DIAGRAM_VIRTUALLY_FRAME" val="{&quot;height&quot;:204,&quot;left&quot;:52.5,&quot;top&quot;:169.5,&quot;width&quot;:326.25}"/>
 </p:tagLst>
 </file>
 
 <file path=ppt/tags/tag2.xml><?xml version="1.0" encoding="utf-8"?>
 <p:tagLst xmlns:p="http://schemas.openxmlformats.org/presentationml/2006/main">
-  <p:tag name="KSO_WM_DIAGRAM_VIRTUALLY_FRAME" val="{&quot;height&quot;:112.5,&quot;left&quot;:166.95,&quot;top&quot;:214.5,&quot;width&quot;:499.05}"/>
+  <p:tag name="KSO_WM_DIAGRAM_VIRTUALLY_FRAME" val="{&quot;height&quot;:204,&quot;left&quot;:52.5,&quot;top&quot;:169.5,&quot;width&quot;:326.25}"/>
 </p:tagLst>
 </file>
 
 <file path=ppt/tags/tag20.xml><?xml version="1.0" encoding="utf-8"?>
 <p:tagLst xmlns:p="http://schemas.openxmlformats.org/presentationml/2006/main">
-  <p:tag name="KSO_WM_DIAGRAM_VIRTUALLY_FRAME" val="{&quot;height&quot;:112.5,&quot;left&quot;:166.95,&quot;top&quot;:214.5,&quot;width&quot;:499.05}"/>
+  <p:tag name="KSO_WM_DIAGRAM_VIRTUALLY_FRAME" val="{&quot;height&quot;:204,&quot;left&quot;:52.5,&quot;top&quot;:169.5,&quot;width&quot;:326.25}"/>
 </p:tagLst>
 </file>
 
@@ -30659,7 +30739,73 @@
 </p:tagLst>
 </file>
 
+<file path=ppt/tags/tag29.xml><?xml version="1.0" encoding="utf-8"?>
+<p:tagLst xmlns:p="http://schemas.openxmlformats.org/presentationml/2006/main">
+  <p:tag name="KSO_WM_DIAGRAM_VIRTUALLY_FRAME" val="{&quot;height&quot;:112.5,&quot;left&quot;:166.95,&quot;top&quot;:214.5,&quot;width&quot;:499.05}"/>
+</p:tagLst>
+</file>
+
 <file path=ppt/tags/tag3.xml><?xml version="1.0" encoding="utf-8"?>
+<p:tagLst xmlns:p="http://schemas.openxmlformats.org/presentationml/2006/main">
+  <p:tag name="KSO_WM_DIAGRAM_VIRTUALLY_FRAME" val="{&quot;height&quot;:204,&quot;left&quot;:52.5,&quot;top&quot;:169.5,&quot;width&quot;:326.25}"/>
+</p:tagLst>
+</file>
+
+<file path=ppt/tags/tag30.xml><?xml version="1.0" encoding="utf-8"?>
+<p:tagLst xmlns:p="http://schemas.openxmlformats.org/presentationml/2006/main">
+  <p:tag name="KSO_WM_DIAGRAM_VIRTUALLY_FRAME" val="{&quot;height&quot;:112.5,&quot;left&quot;:166.95,&quot;top&quot;:214.5,&quot;width&quot;:499.05}"/>
+</p:tagLst>
+</file>
+
+<file path=ppt/tags/tag31.xml><?xml version="1.0" encoding="utf-8"?>
+<p:tagLst xmlns:p="http://schemas.openxmlformats.org/presentationml/2006/main">
+  <p:tag name="KSO_WM_DIAGRAM_VIRTUALLY_FRAME" val="{&quot;height&quot;:112.5,&quot;left&quot;:166.95,&quot;top&quot;:214.5,&quot;width&quot;:499.05}"/>
+</p:tagLst>
+</file>
+
+<file path=ppt/tags/tag32.xml><?xml version="1.0" encoding="utf-8"?>
+<p:tagLst xmlns:p="http://schemas.openxmlformats.org/presentationml/2006/main">
+  <p:tag name="KSO_WM_DIAGRAM_VIRTUALLY_FRAME" val="{&quot;height&quot;:112.5,&quot;left&quot;:166.95,&quot;top&quot;:214.5,&quot;width&quot;:499.05}"/>
+</p:tagLst>
+</file>
+
+<file path=ppt/tags/tag33.xml><?xml version="1.0" encoding="utf-8"?>
+<p:tagLst xmlns:p="http://schemas.openxmlformats.org/presentationml/2006/main">
+  <p:tag name="KSO_WM_DIAGRAM_VIRTUALLY_FRAME" val="{&quot;height&quot;:112.5,&quot;left&quot;:166.95,&quot;top&quot;:214.5,&quot;width&quot;:499.05}"/>
+</p:tagLst>
+</file>
+
+<file path=ppt/tags/tag34.xml><?xml version="1.0" encoding="utf-8"?>
+<p:tagLst xmlns:p="http://schemas.openxmlformats.org/presentationml/2006/main">
+  <p:tag name="KSO_WM_DIAGRAM_VIRTUALLY_FRAME" val="{&quot;height&quot;:112.5,&quot;left&quot;:166.95,&quot;top&quot;:214.5,&quot;width&quot;:499.05}"/>
+</p:tagLst>
+</file>
+
+<file path=ppt/tags/tag35.xml><?xml version="1.0" encoding="utf-8"?>
+<p:tagLst xmlns:p="http://schemas.openxmlformats.org/presentationml/2006/main">
+  <p:tag name="KSO_WM_DIAGRAM_VIRTUALLY_FRAME" val="{&quot;height&quot;:112.5,&quot;left&quot;:166.95,&quot;top&quot;:214.5,&quot;width&quot;:499.05}"/>
+</p:tagLst>
+</file>
+
+<file path=ppt/tags/tag36.xml><?xml version="1.0" encoding="utf-8"?>
+<p:tagLst xmlns:p="http://schemas.openxmlformats.org/presentationml/2006/main">
+  <p:tag name="KSO_WM_DIAGRAM_VIRTUALLY_FRAME" val="{&quot;height&quot;:112.5,&quot;left&quot;:166.95,&quot;top&quot;:214.5,&quot;width&quot;:499.05}"/>
+</p:tagLst>
+</file>
+
+<file path=ppt/tags/tag37.xml><?xml version="1.0" encoding="utf-8"?>
+<p:tagLst xmlns:p="http://schemas.openxmlformats.org/presentationml/2006/main">
+  <p:tag name="KSO_WM_DIAGRAM_VIRTUALLY_FRAME" val="{&quot;height&quot;:112.5,&quot;left&quot;:166.95,&quot;top&quot;:214.5,&quot;width&quot;:499.05}"/>
+</p:tagLst>
+</file>
+
+<file path=ppt/tags/tag38.xml><?xml version="1.0" encoding="utf-8"?>
+<p:tagLst xmlns:p="http://schemas.openxmlformats.org/presentationml/2006/main">
+  <p:tag name="KSO_WM_DIAGRAM_VIRTUALLY_FRAME" val="{&quot;height&quot;:112.5,&quot;left&quot;:166.95,&quot;top&quot;:214.5,&quot;width&quot;:499.05}"/>
+</p:tagLst>
+</file>
+
+<file path=ppt/tags/tag39.xml><?xml version="1.0" encoding="utf-8"?>
 <p:tagLst xmlns:p="http://schemas.openxmlformats.org/presentationml/2006/main">
   <p:tag name="KSO_WM_DIAGRAM_VIRTUALLY_FRAME" val="{&quot;height&quot;:112.5,&quot;left&quot;:166.95,&quot;top&quot;:214.5,&quot;width&quot;:499.05}"/>
 </p:tagLst>
@@ -30667,37 +30813,91 @@
 
 <file path=ppt/tags/tag4.xml><?xml version="1.0" encoding="utf-8"?>
 <p:tagLst xmlns:p="http://schemas.openxmlformats.org/presentationml/2006/main">
+  <p:tag name="KSO_WM_DIAGRAM_VIRTUALLY_FRAME" val="{&quot;height&quot;:204,&quot;left&quot;:52.5,&quot;top&quot;:169.5,&quot;width&quot;:326.25}"/>
+</p:tagLst>
+</file>
+
+<file path=ppt/tags/tag40.xml><?xml version="1.0" encoding="utf-8"?>
+<p:tagLst xmlns:p="http://schemas.openxmlformats.org/presentationml/2006/main">
+  <p:tag name="KSO_WM_DIAGRAM_VIRTUALLY_FRAME" val="{&quot;height&quot;:112.5,&quot;left&quot;:166.95,&quot;top&quot;:214.5,&quot;width&quot;:499.05}"/>
+</p:tagLst>
+</file>
+
+<file path=ppt/tags/tag41.xml><?xml version="1.0" encoding="utf-8"?>
+<p:tagLst xmlns:p="http://schemas.openxmlformats.org/presentationml/2006/main">
+  <p:tag name="KSO_WM_DIAGRAM_VIRTUALLY_FRAME" val="{&quot;height&quot;:112.5,&quot;left&quot;:166.95,&quot;top&quot;:214.5,&quot;width&quot;:499.05}"/>
+</p:tagLst>
+</file>
+
+<file path=ppt/tags/tag42.xml><?xml version="1.0" encoding="utf-8"?>
+<p:tagLst xmlns:p="http://schemas.openxmlformats.org/presentationml/2006/main">
+  <p:tag name="KSO_WM_DIAGRAM_VIRTUALLY_FRAME" val="{&quot;height&quot;:112.5,&quot;left&quot;:166.95,&quot;top&quot;:214.5,&quot;width&quot;:499.05}"/>
+</p:tagLst>
+</file>
+
+<file path=ppt/tags/tag43.xml><?xml version="1.0" encoding="utf-8"?>
+<p:tagLst xmlns:p="http://schemas.openxmlformats.org/presentationml/2006/main">
+  <p:tag name="KSO_WM_DIAGRAM_VIRTUALLY_FRAME" val="{&quot;height&quot;:112.5,&quot;left&quot;:166.95,&quot;top&quot;:214.5,&quot;width&quot;:499.05}"/>
+</p:tagLst>
+</file>
+
+<file path=ppt/tags/tag44.xml><?xml version="1.0" encoding="utf-8"?>
+<p:tagLst xmlns:p="http://schemas.openxmlformats.org/presentationml/2006/main">
+  <p:tag name="KSO_WM_DIAGRAM_VIRTUALLY_FRAME" val="{&quot;height&quot;:112.5,&quot;left&quot;:166.95,&quot;top&quot;:214.5,&quot;width&quot;:499.05}"/>
+</p:tagLst>
+</file>
+
+<file path=ppt/tags/tag45.xml><?xml version="1.0" encoding="utf-8"?>
+<p:tagLst xmlns:p="http://schemas.openxmlformats.org/presentationml/2006/main">
+  <p:tag name="KSO_WM_DIAGRAM_VIRTUALLY_FRAME" val="{&quot;height&quot;:112.5,&quot;left&quot;:166.95,&quot;top&quot;:214.5,&quot;width&quot;:499.05}"/>
+</p:tagLst>
+</file>
+
+<file path=ppt/tags/tag46.xml><?xml version="1.0" encoding="utf-8"?>
+<p:tagLst xmlns:p="http://schemas.openxmlformats.org/presentationml/2006/main">
+  <p:tag name="KSO_WM_DIAGRAM_VIRTUALLY_FRAME" val="{&quot;height&quot;:112.5,&quot;left&quot;:166.95,&quot;top&quot;:214.5,&quot;width&quot;:499.05}"/>
+</p:tagLst>
+</file>
+
+<file path=ppt/tags/tag47.xml><?xml version="1.0" encoding="utf-8"?>
+<p:tagLst xmlns:p="http://schemas.openxmlformats.org/presentationml/2006/main">
+  <p:tag name="KSO_WM_DIAGRAM_VIRTUALLY_FRAME" val="{&quot;height&quot;:112.5,&quot;left&quot;:166.95,&quot;top&quot;:214.5,&quot;width&quot;:499.05}"/>
+</p:tagLst>
+</file>
+
+<file path=ppt/tags/tag48.xml><?xml version="1.0" encoding="utf-8"?>
+<p:tagLst xmlns:p="http://schemas.openxmlformats.org/presentationml/2006/main">
   <p:tag name="KSO_WM_DIAGRAM_VIRTUALLY_FRAME" val="{&quot;height&quot;:112.5,&quot;left&quot;:166.95,&quot;top&quot;:214.5,&quot;width&quot;:499.05}"/>
 </p:tagLst>
 </file>
 
 <file path=ppt/tags/tag5.xml><?xml version="1.0" encoding="utf-8"?>
 <p:tagLst xmlns:p="http://schemas.openxmlformats.org/presentationml/2006/main">
-  <p:tag name="KSO_WM_DIAGRAM_VIRTUALLY_FRAME" val="{&quot;height&quot;:112.5,&quot;left&quot;:166.95,&quot;top&quot;:214.5,&quot;width&quot;:499.05}"/>
+  <p:tag name="KSO_WM_DIAGRAM_VIRTUALLY_FRAME" val="{&quot;height&quot;:204,&quot;left&quot;:52.5,&quot;top&quot;:169.5,&quot;width&quot;:326.25}"/>
 </p:tagLst>
 </file>
 
 <file path=ppt/tags/tag6.xml><?xml version="1.0" encoding="utf-8"?>
 <p:tagLst xmlns:p="http://schemas.openxmlformats.org/presentationml/2006/main">
-  <p:tag name="KSO_WM_DIAGRAM_VIRTUALLY_FRAME" val="{&quot;height&quot;:112.5,&quot;left&quot;:166.95,&quot;top&quot;:214.5,&quot;width&quot;:499.05}"/>
+  <p:tag name="KSO_WM_DIAGRAM_VIRTUALLY_FRAME" val="{&quot;height&quot;:204,&quot;left&quot;:52.5,&quot;top&quot;:169.5,&quot;width&quot;:326.25}"/>
 </p:tagLst>
 </file>
 
 <file path=ppt/tags/tag7.xml><?xml version="1.0" encoding="utf-8"?>
 <p:tagLst xmlns:p="http://schemas.openxmlformats.org/presentationml/2006/main">
-  <p:tag name="KSO_WM_DIAGRAM_VIRTUALLY_FRAME" val="{&quot;height&quot;:112.5,&quot;left&quot;:166.95,&quot;top&quot;:214.5,&quot;width&quot;:499.05}"/>
+  <p:tag name="KSO_WM_DIAGRAM_VIRTUALLY_FRAME" val="{&quot;height&quot;:204,&quot;left&quot;:52.5,&quot;top&quot;:169.5,&quot;width&quot;:326.25}"/>
 </p:tagLst>
 </file>
 
 <file path=ppt/tags/tag8.xml><?xml version="1.0" encoding="utf-8"?>
 <p:tagLst xmlns:p="http://schemas.openxmlformats.org/presentationml/2006/main">
-  <p:tag name="KSO_WM_DIAGRAM_VIRTUALLY_FRAME" val="{&quot;height&quot;:112.5,&quot;left&quot;:166.95,&quot;top&quot;:214.5,&quot;width&quot;:499.05}"/>
+  <p:tag name="KSO_WM_DIAGRAM_VIRTUALLY_FRAME" val="{&quot;height&quot;:204,&quot;left&quot;:52.5,&quot;top&quot;:169.5,&quot;width&quot;:326.25}"/>
 </p:tagLst>
 </file>
 
 <file path=ppt/tags/tag9.xml><?xml version="1.0" encoding="utf-8"?>
 <p:tagLst xmlns:p="http://schemas.openxmlformats.org/presentationml/2006/main">
-  <p:tag name="KSO_WM_DIAGRAM_VIRTUALLY_FRAME" val="{&quot;height&quot;:112.5,&quot;left&quot;:166.95,&quot;top&quot;:214.5,&quot;width&quot;:499.05}"/>
+  <p:tag name="KSO_WM_DIAGRAM_VIRTUALLY_FRAME" val="{&quot;height&quot;:204,&quot;left&quot;:52.5,&quot;top&quot;:169.5,&quot;width&quot;:326.25}"/>
 </p:tagLst>
 </file>
 

</xml_diff>